<commit_message>
Refactor organization handling in user-related classes
- Updated OrganizationController to use organization UUID instead of name for user grouping.
- Changed SignupController to return organization UUID in the signup response and use it for user creation.
- Modified User class to store organization UUID instead of name.
- Adjusted UserController to reflect changes in organization handling.
- Updated integration tests to validate organization UUID usage and ensure proper authorization checks.
- Refined Cve202622730ConverterTest to work with organization UUID.
- Removed unnecessary note-related endpoints from ApiIndexController.
- Updated application.yml to reflect the removal of note-related paths from the API gateway.
</commit_message>
<xml_diff>
--- a/presentation/spring_knowledge_sharing_editable_orgarchive.pptx
+++ b/presentation/spring_knowledge_sharing_editable_orgarchive.pptx
@@ -450,7 +450,7 @@
           <a:lstStyle xmlns:a="http://schemas.openxmlformats.org/drawingml/2006/main"/>
           <a:p xmlns:a="http://schemas.openxmlformats.org/drawingml/2006/main">
             <a:r>
-              <a:t>Guten Tag zusammen. Ich zeige heute an einem fiktiven Spring-Dienst, wie mehrere Schwachstellen zusammenwirken. OrgArchive speichert Notizen und Dokumente für verschiedene Organisationen. Von außen betrachtet gibt es einen Gateway, Authentifizierung, Rollenprüfungen und eine Organisationsgrenze. Trotzdem lässt sich eine Kette bilden: Eine Schwachstelle in Spring Security, eine problematische Debug-Ausgabe, ein schwaches Laborpasswort und eine zweite Schwachstelle in Spring AI. Zuerst erkläre ich Architektur und Mechanismen. Danach zeige ich die komplette Folge direkt in Postman.</a:t>
+              <a:t>Guten Tag zusammen. Ich zeige heute an einem fiktiven Spring-Dienst, wie mehrere Schwachstellen zusammenwirken. OrgArchive speichert Dokumente für verschiedene Organisationen. Von außen betrachtet gibt es einen Gateway, Authentifizierung, Rollenprüfungen und eine Organisationsgrenze. Trotzdem lässt sich eine Kette bilden: Eine Schwachstelle in Spring Security, eine problematische Debug-Ausgabe, ein schwaches Laborpasswort und eine zweite Schwachstelle in Spring AI. Zuerst erkläre ich Architektur und Mechanismen. Danach zeige ich die komplette Folge direkt in Postman.</a:t>
             </a:r>
           </a:p>
         </p:txBody>
@@ -590,7 +590,7 @@
           <a:lstStyle xmlns:a="http://schemas.openxmlformats.org/drawingml/2006/main"/>
           <a:p xmlns:a="http://schemas.openxmlformats.org/drawingml/2006/main">
             <a:r>
-              <a:t>OrgArchive ist ein fiktiver Dienst, in dem Organisationen Notizen und Dokumente ablegen. Der Client spricht mit dem Edge Gateway auf Port 8080. Nur dieser Port ist nach außen veröffentlicht. Der Gateway routet die API an den internen Archive Service; dieser authentifiziert HTTP Basic gegen BCrypt-Hashes in MariaDB. In der Datenbank gibt es die Tabellen app_user, note und document. Eine eigene Organisationstabelle existiert nicht. app_user und note tragen eine organization-Spalte. Dokumente speichern die Organisation im JSON-Feld metadata. Die Verbindung zwischen diesen Werten ist eine logische Mandantenzuordnung, kein Datenbank-Foreign-Key. Diese Unterscheidung ist wichtig: Die Anwendung muss bei jeder Abfrage selbst die passende Organisationsgrenze durchsetzen.</a:t>
+              <a:t>OrgArchive ist ein fiktiver Dienst, in dem Organisationen Dokumente ablegen. Der Client spricht mit dem Edge Gateway auf Port 8080. Nur dieser Port ist nach außen veröffentlicht. Der Gateway routet die API an den internen Archive Service; dieser authentifiziert HTTP Basic gegen BCrypt-Hashes in MariaDB. In der Datenbank gibt es die Tabellen app_user und document. Eine eigene Organisationstabelle existiert nicht. app_user trägt eine organization_uuid-Spalte; Dokumente speichern denselben Wert als organizationUuid im JSON-Feld metadata. Bei der Registrierung erstellt der Server eine zufällige UUID und gibt sie direkt zurück. Sie ist ein Identifikator, kein Geheimnis und kein Ersatz für die Berechtigungsprüfung. Die Verbindung der beiden Werte ist eine logische Mandantenzuordnung, kein Datenbank-Foreign-Key.</a:t>
             </a:r>
           </a:p>
         </p:txBody>
@@ -660,7 +660,7 @@
           <a:lstStyle xmlns:a="http://schemas.openxmlformats.org/drawingml/2006/main"/>
           <a:p xmlns:a="http://schemas.openxmlformats.org/drawingml/2006/main">
             <a:r>
-              <a:t>Auf dem öffentlichen Gateway-Index unter GET / stehen die Routen und beschreibende access-Texte. Dieser Index ist eine Hilfe für die Präsentation; die Texte sind keine Security-Konfiguration. Ohne Index könnte man wahrscheinliche Pfade etwa aus Dokumentation, Client-Code oder beobachtetem Verkehr ableiten, aber nicht automatisch eine vollständige Liste erhalten. Im Archive Service sind /users, /organizations, /notes und /documents auf HTTP-Ebene nur für angemeldete Anfragen freigeschaltet. Die Rollenprüfung erfolgt zusätzlich an Methoden. Für die Listen /users und /organizations ist ADMIN vorgesehen. Die direkte Benutzerabfrage /users/{username} trägt ihre Annotation auf der konkreten Methode und bleibt geschützt. Notizen verlangen ROLE_USER; die Route mit Organisationsnamen prüft außerdem die Mitgliedschaft. Die Dokumentsuche verlangt ROLE_USER und verwendet die gespeicherte Organisation des Kontos. Die Schreibweise der Suchrouten auf dem Slide fasst /search, /search-safe und /search-debug zusammen.</a:t>
+              <a:t>Auf dem öffentlichen Gateway-Index unter GET / stehen die Routen und beschreibende access-Texte. Dieser Index ist eine Hilfe für die Präsentation; die Texte sind keine Security-Konfiguration. Ohne Index könnte man wahrscheinliche Pfade etwa aus Dokumentation, Client-Code oder beobachtetem Verkehr ableiten, aber nicht automatisch eine vollständige Liste erhalten. Im Archive Service sind /users, /organizations und /documents auf HTTP-Ebene nur für angemeldete Anfragen freigeschaltet. Die Rollenprüfung erfolgt zusätzlich an Methoden. Für die Listen /users und /organizations ist ADMIN vorgesehen. Die direkte Benutzerabfrage /users/{username} trägt ihre Annotation auf der konkreten Methode und bleibt geschützt. Die Dokumentsuche verlangt ROLE_USER und verwendet die gespeicherte organizationUuid des Kontos. Der Request enthält ebenfalls einen organizationUuid-Filter; dieser Wert erteilt selbst keine Berechtigung. /search-safe und /search-debug sind zusätzliche Routen für den Vergleich im Demo.</a:t>
             </a:r>
           </a:p>
         </p:txBody>
@@ -805,7 +805,7 @@
           <a:lstStyle xmlns:a="http://schemas.openxmlformats.org/drawingml/2006/main"/>
           <a:p xmlns:a="http://schemas.openxmlformats.org/drawingml/2006/main">
             <a:r>
-              <a:t>Die zweite CVE liegt in Spring AI MariaDB Store, nicht im MariaDB-Server. In diesem Demo läuft kein KI-Modell und keine Vektorsuche; wir verwenden nur den Metadatenfilter-Konverter aus der Spring-AI-Bibliothek. Unser Archive Service verwendet Version 1.0.3 und ruft MariaDBFilterExpressionConverter für einen Metadatenfilter auf. Die zulässige Organisation stammt aus dem gespeicherten Benutzerkonto und wird als JDBC-Parameter gebunden. Zusätzlich soll ein Filter aus dem Request ausgewertet werden. Der Converter setzt dessen String-Wert jedoch ohne korrektes Escaping in ein SQL-Fragment ein. Mit dem Wert atlas-consulting' OR '1'='1 verlässt das Anführungszeichen den String und ergänzt eine OR-Bedingung. Da SQL AND vor OR auswertet, kann dieser Teil die vorherige Organisationsbedingung überstimmen. Die Anwendung gibt dann Dokumente anderer Organisationen zurück. Die Route /documents/search-safe ist nur ein eigener Vergleich im Demo-Projekt: Sie bindet beide Werte und liefert für denselben manipulierten Input keine fremden Treffer. Das ist keine gepatchte Spring-AI-Implementierung. Spring AI 1.0.4 behebt die CVE im 1.0-Zweig. Der Demo-Request enthält nur noch den relevanten Metadatenfilter organization.</a:t>
+              <a:t>Die zweite CVE liegt in Spring AI MariaDB Store, nicht im MariaDB-Server. In diesem Demo läuft kein KI-Modell und keine Vektorsuche; wir verwenden nur den Metadatenfilter-Konverter aus der Spring-AI-Bibliothek. Unser Archive Service verwendet Version 1.0.3 und ruft MariaDBFilterExpressionConverter für einen Metadatenfilter auf. Die zulässige organizationUuid stammt aus dem gespeicherten Benutzerkonto und wird als JDBC-Parameter gebunden. Zusätzlich soll ein Filter aus dem Request ausgewertet werden. Der Converter setzt dessen String-Wert jedoch ohne korrektes Escaping in ein SQL-Fragment ein. Mit dem Wert 786298a5-8c02-56ce-ba8f-d2b41ec3333c' OR '1'='1 verlässt das Anführungszeichen den String und ergänzt eine OR-Bedingung. Da SQL AND vor OR auswertet, kann dieser Teil die vorherige Organisationsbedingung überstimmen. Die Anwendung gibt dann Dokumente anderer Organisationen zurück. Die Route /documents/search-safe ist nur ein eigener Vergleich im Demo-Projekt: Sie bindet beide Werte und liefert für denselben manipulierten Input keine fremden Treffer. Das ist keine gepatchte Spring-AI-Implementierung. Spring AI 1.0.4 behebt die CVE im 1.0-Zweig.</a:t>
             </a:r>
           </a:p>
           <a:p xmlns:a="http://schemas.openxmlformats.org/drawingml/2006/main">
@@ -950,7 +950,7 @@
           <a:lstStyle xmlns:a="http://schemas.openxmlformats.org/drawingml/2006/main"/>
           <a:p xmlns:a="http://schemas.openxmlformats.org/drawingml/2006/main">
             <a:r>
-              <a:t>Jetzt wechsle ich vom Foliensatz zur Postman Collection mit elf Requests. Zuerst zeigt GET / den öffentlichen Demo-Index. Anonyme Anfragen an /users und /notes liefern 401. Danach registrieren wir einen normalen Benutzer in einer neuen Trial-Organisation und sehen: die eigenen Notizen sind leer. Request 6 ist der erste unberechtigte Zugriff: Das normale Konto erhält durch CVE-2025-22223 die für ADMIN vorgesehene Benutzerliste. Darin sehen wir auch die Organisationsnamen. Request 7 verwendet debug=true und zeigt Passwort-Hashes für alle Benutzer. Ich erkläre, dass ein Offline-Vergleich mit einer kurzen Liste schwacher Passwörter für Annas Hash den Laborwert sunshine ergibt; diesen Vergleich führe ich hier nicht live aus. Das Passwort ist bereits als annaPassword in der Collection gespeichert. Mit Annas Konto zeigen die letzten vier Requests: normale Dokumentsuche, fremde Organisation ohne Treffer, manipulierter Filter mit fremden Dokumenten und dieselbe Eingabe auf /search-safe ohne fremde Treffer.</a:t>
+              <a:t>Jetzt wechsle ich vom Foliensatz zur Postman Collection mit zehn Requests. Zuerst zeigt GET / den öffentlichen Demo-Index. Eine anonyme Anfrage an /users liefert 401. Danach registrieren wir einen normalen Benutzer. Der Signup-Response enthält eine neue organizationUuid. Die Suche nach Dokumenten dieser UUID liefert eine leere Liste. Request 5 ist der erste unberechtigte Zugriff: Das normale Konto erhält durch CVE-2025-22223 die für ADMIN vorgesehene Benutzerliste. Darin sehen wir auch die Organisations-UUIDs. Request 6 verwendet debug=true und zeigt Passwort-Hashes für alle Benutzer. Ich erkläre, dass ein Offline-Vergleich mit einer kurzen Liste schwacher Passwörter für Annas Hash den Laborwert sunshine ergibt; diesen Vergleich führe ich hier nicht live aus. Das Passwort ist bereits als annaPassword in der Collection gespeichert. Mit Annas Konto zeigen die letzten vier Requests: normale Dokumentsuche, fremde UUID ohne Treffer, manipulierter Filter mit fremden Dokumenten und dieselbe Eingabe auf /search-safe ohne fremde Treffer.</a:t>
             </a:r>
           </a:p>
         </p:txBody>
@@ -8740,7 +8740,7 @@
                 <a:ea typeface="Arial"/>
                 <a:cs typeface="Arial"/>
               </a:rPr>
-              <a:t>Drei Tabellen; organization ist der logische Mandantenschlüssel, kein Foreign Key.</a:t>
+              <a:t>Zwei Tabellen; organizationUuid verbindet Benutzer und Dokumente logisch.</a:t>
             </a:r>
           </a:p>
         </p:txBody>
@@ -9147,7 +9147,7 @@
                 <a:ea typeface="Arial"/>
                 <a:cs typeface="Arial"/>
               </a:rPr>
-              <a:t>role · organization</a:t>
+              <a:t>role · organization_uuid</a:t>
             </a:r>
           </a:p>
         </p:txBody>
@@ -9372,7 +9372,7 @@
                 <a:ea typeface="Arial"/>
                 <a:cs typeface="Arial"/>
               </a:rPr>
-              <a:t>note</a:t>
+              <a:t>organizationUuid</a:t>
             </a:r>
           </a:p>
         </p:txBody>
@@ -9531,7 +9531,7 @@
                 <a:ea typeface="Arial"/>
                 <a:cs typeface="Arial"/>
               </a:rPr>
-              <a:t>id · title · body</a:t>
+              <a:t>UUID je Organisation</a:t>
             </a:r>
           </a:p>
           <a:p xmlns:a="http://schemas.openxmlformats.org/drawingml/2006/main">
@@ -9554,7 +9554,7 @@
                 <a:ea typeface="Arial"/>
                 <a:cs typeface="Arial"/>
               </a:rPr>
-              <a:t>organization</a:t>
+              <a:t>Bei Signup vergeben</a:t>
             </a:r>
           </a:p>
         </p:txBody>
@@ -9961,7 +9961,7 @@
                 <a:ea typeface="Arial"/>
                 <a:cs typeface="Arial"/>
               </a:rPr>
-              <a:t>metadata.organization</a:t>
+              <a:t>metadata.organizationUuid</a:t>
             </a:r>
           </a:p>
         </p:txBody>
@@ -12881,7 +12881,7 @@
                 <a:ea typeface="Arial"/>
                 <a:cs typeface="Arial"/>
               </a:rPr>
-              <a:t>GET /notes · /organizations/{org}/notes</a:t>
+              <a:t>POST /documents/search</a:t>
             </a:r>
           </a:p>
         </p:txBody>
@@ -13199,7 +13199,7 @@
                 <a:ea typeface="Arial"/>
                 <a:cs typeface="Arial"/>
               </a:rPr>
-              <a:t>Eigene bzw. gemeinsame Notizen</a:t>
+              <a:t>Suche nach organizationUuid</a:t>
             </a:r>
           </a:p>
         </p:txBody>
@@ -13389,7 +13389,7 @@
                 <a:ea typeface="Arial"/>
                 <a:cs typeface="Arial"/>
               </a:rPr>
-              <a:t>POST /documents/search{,-safe,-debug}</a:t>
+              <a:t>POST /documents/search-safe · /search-debug</a:t>
             </a:r>
           </a:p>
         </p:txBody>
@@ -13707,7 +13707,7 @@
                 <a:ea typeface="Arial"/>
                 <a:cs typeface="Arial"/>
               </a:rPr>
-              <a:t>Suche mit Organisationsfilter</a:t>
+              <a:t>Vergleich und Debug-Ausgabe</a:t>
             </a:r>
           </a:p>
         </p:txBody>
@@ -17823,7 +17823,7 @@
                 <a:ea typeface="Arial"/>
                 <a:cs typeface="Arial"/>
               </a:rPr>
-              <a:t>Request.organization</a:t>
+              <a:t>Request.organizationUuid</a:t>
             </a:r>
           </a:p>
         </p:txBody>
@@ -18620,7 +18620,7 @@
                 <a:ea typeface="Arial"/>
                 <a:cs typeface="Arial"/>
               </a:rPr>
-              <a:t>JSON_VALUE(metadata, '$.organization') = ?</a:t>
+              <a:t>JSON_VALUE(metadata, '$.organizationUuid') = ?</a:t>
             </a:r>
           </a:p>
         </p:txBody>
@@ -18971,7 +18971,7 @@
                 <a:ea typeface="Arial"/>
                 <a:cs typeface="Arial"/>
               </a:rPr>
-              <a:t>atlas-consulting' OR '1'='1</a:t>
+              <a:t>786298a5-…' OR '1'='1</a:t>
             </a:r>
           </a:p>
         </p:txBody>
@@ -21433,7 +21433,7 @@
                 <a:ea typeface="Arial"/>
                 <a:cs typeface="Arial"/>
               </a:rPr>
-              <a:t>11 Requests · Annas Laborpasswort ist bereits hinterlegt</a:t>
+              <a:t>10 Requests · Annas Laborpasswort ist bereits hinterlegt</a:t>
             </a:r>
           </a:p>
         </p:txBody>
@@ -22007,7 +22007,7 @@
                 <a:ea typeface="Arial"/>
                 <a:cs typeface="Arial"/>
               </a:rPr>
-              <a:t>1–5</a:t>
+              <a:t>1–4</a:t>
             </a:r>
           </a:p>
         </p:txBody>
@@ -22325,7 +22325,7 @@
                 <a:ea typeface="Arial"/>
                 <a:cs typeface="Arial"/>
               </a:rPr>
-              <a:t>API-Index · anonyme 401 · eigene Notizen</a:t>
+              <a:t>API-Index · anonyme 401 · Signup-UUID · eigene Dokumente</a:t>
             </a:r>
           </a:p>
         </p:txBody>
@@ -22550,7 +22550,7 @@
                 <a:ea typeface="Arial"/>
                 <a:cs typeface="Arial"/>
               </a:rPr>
-              <a:t>6–7</a:t>
+              <a:t>5–6</a:t>
             </a:r>
           </a:p>
         </p:txBody>
@@ -23093,7 +23093,7 @@
                 <a:ea typeface="Arial"/>
                 <a:cs typeface="Arial"/>
               </a:rPr>
-              <a:t>8–9</a:t>
+              <a:t>7–8</a:t>
             </a:r>
           </a:p>
         </p:txBody>
@@ -23411,7 +23411,7 @@
                 <a:ea typeface="Arial"/>
                 <a:cs typeface="Arial"/>
               </a:rPr>
-              <a:t>Eigene Organisation · fremde Organisation ohne Treffer</a:t>
+              <a:t>Eigene UUID · fremde UUID ohne Treffer</a:t>
             </a:r>
           </a:p>
         </p:txBody>
@@ -23636,7 +23636,7 @@
                 <a:ea typeface="Arial"/>
                 <a:cs typeface="Arial"/>
               </a:rPr>
-              <a:t>10–11</a:t>
+              <a:t>9–10</a:t>
             </a:r>
           </a:p>
         </p:txBody>

</xml_diff>

<commit_message>
fix: remove organizationUuid from users endpoint
</commit_message>
<xml_diff>
--- a/presentation/spring_knowledge_sharing_editable_orgarchive.pptx
+++ b/presentation/spring_knowledge_sharing_editable_orgarchive.pptx
@@ -660,7 +660,7 @@
           <a:lstStyle xmlns:a="http://schemas.openxmlformats.org/drawingml/2006/main"/>
           <a:p xmlns:a="http://schemas.openxmlformats.org/drawingml/2006/main">
             <a:r>
-              <a:t>Auf dem öffentlichen Gateway-Index unter GET / stehen die Routen und beschreibende access-Texte. Dieser Index ist eine Hilfe für die Präsentation; die Texte sind keine Security-Konfiguration. Ohne Index könnte man wahrscheinliche Pfade etwa aus Dokumentation, Client-Code oder beobachtetem Verkehr ableiten, aber nicht automatisch eine vollständige Liste erhalten. Im Archive Service sind /users, /organizations und /documents auf HTTP-Ebene nur für angemeldete Anfragen freigeschaltet. Die Rollenprüfung erfolgt zusätzlich an Methoden. Für die Listen /users und /organizations ist ADMIN vorgesehen. Die direkte Benutzerabfrage /users/{username} trägt ihre Annotation auf der konkreten Methode und bleibt geschützt. Die Dokumentsuche verlangt ROLE_USER und verwendet die gespeicherte organizationUuid des Kontos. Der Request enthält ebenfalls einen organizationUuid-Filter; dieser Wert erteilt selbst keine Berechtigung. /search-safe und /search-debug sind zusätzliche Routen für den Vergleich im Demo.</a:t>
+              <a:t>Auf dem öffentlichen Gateway-Index unter GET / stehen die Routen und beschreibende access-Texte. Dieser Index ist eine Hilfe für die Präsentation; die Texte sind keine Security-Konfiguration. Ohne Index könnte man wahrscheinliche Pfade etwa aus Dokumentation, Client-Code oder beobachtetem Verkehr ableiten, aber nicht automatisch eine vollständige Liste erhalten. Im Archive Service sind /users und /documents auf HTTP-Ebene nur für angemeldete Anfragen freigeschaltet. Die Rollenprüfung erfolgt zusätzlich an Methoden. Für die Liste /users ist ADMIN vorgesehen. Die direkte Benutzerabfrage /users/{username} trägt ihre Annotation auf der konkreten Methode und bleibt geschützt. Beide Benutzerantworten enthalten keine Organisations-UUID. Einen Endpunkt für eine Organisationsliste gibt es nicht. Die Dokumentsuche verlangt ROLE_USER und verwendet die gespeicherte organizationUuid des Kontos. Der Request enthält ebenfalls einen organizationUuid-Filter; dieser Wert erteilt selbst keine Berechtigung. /search-safe und /search-debug sind zusätzliche Routen für den Vergleich im Demo.</a:t>
             </a:r>
           </a:p>
         </p:txBody>
@@ -730,7 +730,7 @@
           <a:lstStyle xmlns:a="http://schemas.openxmlformats.org/drawingml/2006/main"/>
           <a:p xmlns:a="http://schemas.openxmlformats.org/drawingml/2006/main">
             <a:r>
-              <a:t>Die erste CVE betrifft die Suche nach Methoden-Sicherheitsannotationen. In unserem Projekt ist @EnableMethodSecurity aktiv. Das generische Interface AdminQuery&lt;F,R&gt; deklariert list und trägt dort @PreAuthorize("hasRole('ADMIN')"). UserController und OrganizationController implementieren dieses Interface, aber ihre konkreten list-Methoden haben keine eigene Annotation. In den betroffenen Spring-Security-Versionen 6.4.0 bis 6.4.3 wird die geerbte Annotation auf parameterisierten Typen unter diesen Bedingungen nicht zuverlässig gefunden. Wichtig: Der HTTP-Filter fordert für /users weiter eine Anmeldung. Der Angreifer registriert deshalb ein normales ROLE_USER-Konto und ruft erst dann die Liste auf. Er erhält dadurch keine ADMIN-Rolle. Die direkt annotierte Route /users/anna antwortet weiterhin mit 403. Spring Security 6.4.4 behebt die CVE; alternativ kann die Annotation auf der Zielmethode stehen.</a:t>
+              <a:t>Die erste CVE betrifft die Suche nach Methoden-Sicherheitsannotationen. In unserem Projekt ist @EnableMethodSecurity aktiv. Das generische Interface AdminQuery&lt;F,R&gt; deklariert list und trägt dort @PreAuthorize("hasRole('ADMIN')"). UserController implementiert dieses Interface, aber seine konkrete list-Methode hat keine eigene Annotation. In den betroffenen Spring-Security-Versionen 6.4.0 bis 6.4.3 wird die geerbte Annotation auf parameterisierten Typen unter diesen Bedingungen nicht zuverlässig gefunden. Wichtig: Der HTTP-Filter fordert für /users weiter eine Anmeldung. Der Angreifer registriert deshalb ein normales ROLE_USER-Konto und ruft erst dann die Liste auf. Er erhält dadurch keine ADMIN-Rolle und sieht zunächst keine Organisations-UUID. Die direkt annotierte Route /users/anna antwortet weiterhin mit 403. Spring Security 6.4.4 behebt die CVE; alternativ kann die Annotation auf der Zielmethode stehen.</a:t>
             </a:r>
           </a:p>
           <a:p xmlns:a="http://schemas.openxmlformats.org/drawingml/2006/main">
@@ -805,7 +805,7 @@
           <a:lstStyle xmlns:a="http://schemas.openxmlformats.org/drawingml/2006/main"/>
           <a:p xmlns:a="http://schemas.openxmlformats.org/drawingml/2006/main">
             <a:r>
-              <a:t>Die zweite CVE liegt in Spring AI MariaDB Store, nicht im MariaDB-Server. In diesem Demo läuft kein KI-Modell und keine Vektorsuche; wir verwenden nur den Metadatenfilter-Konverter aus der Spring-AI-Bibliothek. Unser Archive Service verwendet Version 1.0.3 und ruft MariaDBFilterExpressionConverter für einen Metadatenfilter auf. Die zulässige organizationUuid stammt aus dem gespeicherten Benutzerkonto und wird als JDBC-Parameter gebunden. Zusätzlich soll ein Filter aus dem Request ausgewertet werden. Der Converter setzt dessen String-Wert jedoch ohne korrektes Escaping in ein SQL-Fragment ein. Mit dem Wert 786298a5-8c02-56ce-ba8f-d2b41ec3333c' OR '1'='1 verlässt das Anführungszeichen den String und ergänzt eine OR-Bedingung. Da SQL AND vor OR auswertet, kann dieser Teil die vorherige Organisationsbedingung überstimmen. Die Anwendung gibt dann Dokumente anderer Organisationen zurück. Die Route /documents/search-safe ist nur ein eigener Vergleich im Demo-Projekt: Sie bindet beide Werte und liefert für denselben manipulierten Input keine fremden Treffer. Das ist keine gepatchte Spring-AI-Implementierung. Spring AI 1.0.4 behebt die CVE im 1.0-Zweig.</a:t>
+              <a:t>Die zweite CVE liegt in Spring AI MariaDB Store, nicht im MariaDB-Server. In diesem Demo läuft kein KI-Modell und keine Vektorsuche; wir verwenden nur den Metadatenfilter-Konverter aus der Spring-AI-Bibliothek. Unser Archive Service verwendet Version 1.0.3 und ruft MariaDBFilterExpressionConverter für einen Metadatenfilter auf. Die zulässige organizationUuid stammt aus dem gespeicherten Benutzerkonto und wird als JDBC-Parameter gebunden. Zusätzlich soll ein Filter aus dem Request ausgewertet werden. Der Converter setzt dessen String-Wert jedoch ohne korrektes Escaping in ein SQL-Fragment ein. Der Angreifer kennt nur die UUID seiner eigenen Registrierung. Mit dieser UUID und dem Suffix ' OR '1'='1 verlässt das Anführungszeichen den String und ergänzt eine OR-Bedingung. Da SQL AND vor OR auswertet, kann dieser Teil die vorherige Organisationsbedingung überstimmen. Die Anwendung gibt dann Dokumente anderer Organisationen und deren UUIDs zurück. Die Route /documents/search-safe ist nur ein eigener Vergleich im Demo-Projekt: Sie bindet beide Werte und liefert für denselben manipulierten Input keine fremden Treffer. Das ist keine gepatchte Spring-AI-Implementierung. Spring AI 1.0.4 behebt die CVE im 1.0-Zweig.</a:t>
             </a:r>
           </a:p>
           <a:p xmlns:a="http://schemas.openxmlformats.org/drawingml/2006/main">
@@ -950,7 +950,7 @@
           <a:lstStyle xmlns:a="http://schemas.openxmlformats.org/drawingml/2006/main"/>
           <a:p xmlns:a="http://schemas.openxmlformats.org/drawingml/2006/main">
             <a:r>
-              <a:t>Jetzt wechsle ich vom Foliensatz zur Postman Collection mit zehn Requests. Zuerst zeigt GET / den öffentlichen Demo-Index. Eine anonyme Anfrage an /users liefert 401. Danach registrieren wir einen normalen Benutzer. Der Signup-Response enthält eine neue organizationUuid. Die Suche nach Dokumenten dieser UUID liefert eine leere Liste. Request 5 ist der erste unberechtigte Zugriff: Das normale Konto erhält durch CVE-2025-22223 die für ADMIN vorgesehene Benutzerliste. Darin sehen wir auch die Organisations-UUIDs. Request 6 verwendet debug=true und zeigt Passwort-Hashes für alle Benutzer. Ich erkläre, dass ein Offline-Vergleich mit einer kurzen Liste schwacher Passwörter für Annas Hash den Laborwert sunshine ergibt; diesen Vergleich führe ich hier nicht live aus. Das Passwort ist bereits als annaPassword in der Collection gespeichert. Mit Annas Konto zeigen die letzten vier Requests: normale Dokumentsuche, fremde UUID ohne Treffer, manipulierter Filter mit fremden Dokumenten und dieselbe Eingabe auf /search-safe ohne fremde Treffer.</a:t>
+              <a:t>Jetzt wechsle ich vom Foliensatz zur Postman Collection mit neun Requests. Zuerst zeigt GET / den öffentlichen Demo-Index. Eine anonyme Anfrage an /users liefert 401. Danach registrieren wir einen normalen Benutzer. Der Signup-Response enthält eine neue organizationUuid. Die Suche nach Dokumenten dieser UUID liefert eine leere Liste. Request 5 ist der erste unberechtigte Zugriff: Das normale Konto erhält durch CVE-2025-22223 die für ADMIN vorgesehene Benutzerliste. Die Liste enthält keine Organisations-UUID. Request 6 verwendet debug=true und zeigt Passwort-Hashes für alle Benutzer. Ich erkläre, dass ein Offline-Vergleich mit einer kurzen Liste schwacher Passwörter für Annas Hash den Laborwert sunshine ergibt; diesen Vergleich führe ich hier nicht live aus. Das Passwort ist bereits als annaPassword in der Collection gespeichert. Request 7 sucht als Anna mit der UUID unserer eigenen Registrierung und findet nichts. Request 8 hängt an genau diese bekannte UUID eine SQL-Bedingung und erhält fremde Dokumente samt UUIDs. Request 9 zeigt, dass derselbe Wert bei der parametrisierten Abfrage keine Treffer liefert.</a:t>
             </a:r>
           </a:p>
         </p:txBody>
@@ -11865,7 +11865,7 @@
                 <a:ea typeface="Arial"/>
                 <a:cs typeface="Arial"/>
               </a:rPr>
-              <a:t>GET /users · /organizations</a:t>
+              <a:t>GET /users</a:t>
             </a:r>
           </a:p>
         </p:txBody>
@@ -12183,7 +12183,7 @@
                 <a:ea typeface="Arial"/>
                 <a:cs typeface="Arial"/>
               </a:rPr>
-              <a:t>Administrative Listen</a:t>
+              <a:t>Administrative Benutzerliste</a:t>
             </a:r>
           </a:p>
         </p:txBody>
@@ -18971,7 +18971,7 @@
                 <a:ea typeface="Arial"/>
                 <a:cs typeface="Arial"/>
               </a:rPr>
-              <a:t>786298a5-…' OR '1'='1</a:t>
+              <a:t>eigene UUID' OR '1'='1</a:t>
             </a:r>
           </a:p>
         </p:txBody>
@@ -21433,7 +21433,7 @@
                 <a:ea typeface="Arial"/>
                 <a:cs typeface="Arial"/>
               </a:rPr>
-              <a:t>10 Requests · Annas Laborpasswort ist bereits hinterlegt</a:t>
+              <a:t>9 Requests · Annas Laborpasswort ist bereits hinterlegt</a:t>
             </a:r>
           </a:p>
         </p:txBody>
@@ -23093,7 +23093,7 @@
                 <a:ea typeface="Arial"/>
                 <a:cs typeface="Arial"/>
               </a:rPr>
-              <a:t>7–8</a:t>
+              <a:t>7</a:t>
             </a:r>
           </a:p>
         </p:txBody>
@@ -23411,7 +23411,7 @@
                 <a:ea typeface="Arial"/>
                 <a:cs typeface="Arial"/>
               </a:rPr>
-              <a:t>Eigene UUID · fremde UUID ohne Treffer</a:t>
+              <a:t>Unsere UUID · keine Treffer</a:t>
             </a:r>
           </a:p>
         </p:txBody>
@@ -23636,7 +23636,7 @@
                 <a:ea typeface="Arial"/>
                 <a:cs typeface="Arial"/>
               </a:rPr>
-              <a:t>9–10</a:t>
+              <a:t>8–9</a:t>
             </a:r>
           </a:p>
         </p:txBody>
@@ -23954,7 +23954,7 @@
                 <a:ea typeface="Arial"/>
                 <a:cs typeface="Arial"/>
               </a:rPr>
-              <a:t>Fremde Dokumente · sichere Abfrage ohne Treffer</a:t>
+              <a:t>Fremde Dokumente und UUIDs · sichere Abfrage ohne Treffer</a:t>
             </a:r>
           </a:p>
         </p:txBody>

</xml_diff>